<commit_message>
Templates: patterns deck, optional XSD validation, render helper
- EL_Claude_Template_Patterns_v001.pptx: 19 example slides (one per layout plus
  status chips and report workflow pills, and a diagram-parts gallery), neutral
  dummy text, native shapes, grey "Picture goes here" box.
- kit/patterns.py builds it; kit/build_template.py orchestrates.
- Layout chip placeholder no longer carries its own geometry: LibreOffice drew its
  prompt text onto slides. set_status() writes the rounded shape on the slide chip.
- check_template.py: optional --xsd DIR validation against ISO/IEC 29500-4.
- kit/render.sh: LibreOffice to PNG helper.

Co-Authored-By: Claude Sonnet 5.5 <noreply@anthropic.com>
Claude-Session: https://claude.ai/code/session_01FfWcfoJhq3imaT6SagMGy6
</commit_message>
<xml_diff>
--- a/Reporting/Claude Presents/Templates/EL_Claude_Template_v001.pptx
+++ b/Reporting/Claude Presents/Templates/EL_Claude_Template_v001.pptx
@@ -1304,12 +1304,6 @@
             <a:off x="10085832" y="530352"/>
             <a:ext cx="1554480" cy="365760"/>
           </a:xfrm>
-          <a:prstGeom prst="roundRect">
-            <a:avLst>
-              <a:gd name="adj" fmla="val 30000"/>
-            </a:avLst>
-          </a:prstGeom>
-          <a:noFill/>
         </p:spPr>
         <p:txBody>
           <a:bodyPr vert="horz" wrap="square" lIns="54864" tIns="0" rIns="54864" bIns="0" rtlCol="0" anchor="ctr">
@@ -5088,12 +5082,6 @@
             <a:off x="10085832" y="530352"/>
             <a:ext cx="1554480" cy="365760"/>
           </a:xfrm>
-          <a:prstGeom prst="roundRect">
-            <a:avLst>
-              <a:gd name="adj" fmla="val 30000"/>
-            </a:avLst>
-          </a:prstGeom>
-          <a:noFill/>
         </p:spPr>
         <p:txBody>
           <a:bodyPr vert="horz" wrap="square" lIns="54864" tIns="0" rIns="54864" bIns="0" rtlCol="0" anchor="ctr">
@@ -5399,12 +5387,6 @@
             <a:off x="10085832" y="530352"/>
             <a:ext cx="1554480" cy="365760"/>
           </a:xfrm>
-          <a:prstGeom prst="roundRect">
-            <a:avLst>
-              <a:gd name="adj" fmla="val 30000"/>
-            </a:avLst>
-          </a:prstGeom>
-          <a:noFill/>
         </p:spPr>
         <p:txBody>
           <a:bodyPr vert="horz" wrap="square" lIns="54864" tIns="0" rIns="54864" bIns="0" rtlCol="0" anchor="ctr">
@@ -5938,12 +5920,6 @@
             <a:off x="10085832" y="530352"/>
             <a:ext cx="1554480" cy="365760"/>
           </a:xfrm>
-          <a:prstGeom prst="roundRect">
-            <a:avLst>
-              <a:gd name="adj" fmla="val 30000"/>
-            </a:avLst>
-          </a:prstGeom>
-          <a:noFill/>
         </p:spPr>
         <p:txBody>
           <a:bodyPr vert="horz" wrap="square" lIns="54864" tIns="0" rIns="54864" bIns="0" rtlCol="0" anchor="ctr">
@@ -6421,12 +6397,6 @@
             <a:off x="10085832" y="530352"/>
             <a:ext cx="1554480" cy="365760"/>
           </a:xfrm>
-          <a:prstGeom prst="roundRect">
-            <a:avLst>
-              <a:gd name="adj" fmla="val 30000"/>
-            </a:avLst>
-          </a:prstGeom>
-          <a:noFill/>
         </p:spPr>
         <p:txBody>
           <a:bodyPr vert="horz" wrap="square" lIns="54864" tIns="0" rIns="54864" bIns="0" rtlCol="0" anchor="ctr">
@@ -6959,12 +6929,6 @@
             <a:off x="10085832" y="530352"/>
             <a:ext cx="1554480" cy="365760"/>
           </a:xfrm>
-          <a:prstGeom prst="roundRect">
-            <a:avLst>
-              <a:gd name="adj" fmla="val 30000"/>
-            </a:avLst>
-          </a:prstGeom>
-          <a:noFill/>
         </p:spPr>
         <p:txBody>
           <a:bodyPr vert="horz" wrap="square" lIns="54864" tIns="0" rIns="54864" bIns="0" rtlCol="0" anchor="ctr">
@@ -7950,12 +7914,6 @@
             <a:off x="10085832" y="530352"/>
             <a:ext cx="1554480" cy="365760"/>
           </a:xfrm>
-          <a:prstGeom prst="roundRect">
-            <a:avLst>
-              <a:gd name="adj" fmla="val 30000"/>
-            </a:avLst>
-          </a:prstGeom>
-          <a:noFill/>
         </p:spPr>
         <p:txBody>
           <a:bodyPr vert="horz" wrap="square" lIns="54864" tIns="0" rIns="54864" bIns="0" rtlCol="0" anchor="ctr">
@@ -9010,12 +8968,6 @@
             <a:off x="10085832" y="530352"/>
             <a:ext cx="1554480" cy="365760"/>
           </a:xfrm>
-          <a:prstGeom prst="roundRect">
-            <a:avLst>
-              <a:gd name="adj" fmla="val 30000"/>
-            </a:avLst>
-          </a:prstGeom>
-          <a:noFill/>
         </p:spPr>
         <p:txBody>
           <a:bodyPr vert="horz" wrap="square" lIns="54864" tIns="0" rIns="54864" bIns="0" rtlCol="0" anchor="ctr">

</xml_diff>